<commit_message>
feat(forex): PPTX forex 100% decompose (layers) — fond + logo NDS + chip + QR + bandeau + 7 logos partenaires isoles (chacun deplacable/remplacable) + 4 textes editables. Remplace les PPTX forex 'plate+textes'. Scripts gen_forex_layers.py + gen_pptx_forex_layers.js.
</commit_message>
<xml_diff>
--- a/admin/public/nds/kit-digital/svg/forex_70x70_bar-1-editable.pptx
+++ b/admin/public/nds/kit-digital/svg/forex_70x70_bar-1-editable.pptx
@@ -870,7 +870,7 @@
       </p:grpSpPr>
       <p:pic>
         <p:nvPicPr>
-          <p:cNvPr id="2" name="Image 0" descr="/home/claude/vid/forex_plates/plate_forex_70x70_bar-1.png">    </p:cNvPr>
+          <p:cNvPr id="2" name="Image 0" descr="/home/claude/vid/forex_layers/forex_70x70_bar-1__bg.png">    </p:cNvPr>
           <p:cNvPicPr>
             <a:picLocks noChangeAspect="1"/>
           </p:cNvPicPr>
@@ -892,9 +892,273 @@
           </a:prstGeom>
         </p:spPr>
       </p:pic>
+      <p:pic>
+        <p:nvPicPr>
+          <p:cNvPr id="3" name="Image 1" descr="/home/claude/vid/forex_layers/forex_70x70_bar-1__logo_nds.png">    </p:cNvPr>
+          <p:cNvPicPr>
+            <a:picLocks noChangeAspect="1"/>
+          </p:cNvPicPr>
+          <p:nvPr/>
+        </p:nvPicPr>
+        <p:blipFill>
+          <a:blip r:embed="rId2"/>
+          <a:stretch>
+            <a:fillRect/>
+          </a:stretch>
+        </p:blipFill>
+        <p:spPr>
+          <a:xfrm>
+            <a:off x="9028800" y="1022400"/>
+            <a:ext cx="7178400" cy="2311200"/>
+          </a:xfrm>
+          <a:prstGeom prst="rect">
+            <a:avLst/>
+          </a:prstGeom>
+        </p:spPr>
+      </p:pic>
+      <p:pic>
+        <p:nvPicPr>
+          <p:cNvPr id="4" name="Image 2" descr="/home/claude/vid/forex_layers/forex_70x70_bar-1__chip_station.png">    </p:cNvPr>
+          <p:cNvPicPr>
+            <a:picLocks noChangeAspect="1"/>
+          </p:cNvPicPr>
+          <p:nvPr/>
+        </p:nvPicPr>
+        <p:blipFill>
+          <a:blip r:embed="rId3"/>
+          <a:stretch>
+            <a:fillRect/>
+          </a:stretch>
+        </p:blipFill>
+        <p:spPr>
+          <a:xfrm>
+            <a:off x="20124000" y="1173600"/>
+            <a:ext cx="3679200" cy="1310400"/>
+          </a:xfrm>
+          <a:prstGeom prst="rect">
+            <a:avLst/>
+          </a:prstGeom>
+        </p:spPr>
+      </p:pic>
+      <p:pic>
+        <p:nvPicPr>
+          <p:cNvPr id="5" name="Image 3" descr="/home/claude/vid/forex_layers/forex_70x70_bar-1__qr.png">    </p:cNvPr>
+          <p:cNvPicPr>
+            <a:picLocks noChangeAspect="1"/>
+          </p:cNvPicPr>
+          <p:nvPr/>
+        </p:nvPicPr>
+        <p:blipFill>
+          <a:blip r:embed="rId4"/>
+          <a:stretch>
+            <a:fillRect/>
+          </a:stretch>
+        </p:blipFill>
+        <p:spPr>
+          <a:xfrm>
+            <a:off x="7387200" y="7790400"/>
+            <a:ext cx="10418400" cy="10418400"/>
+          </a:xfrm>
+          <a:prstGeom prst="rect">
+            <a:avLst/>
+          </a:prstGeom>
+        </p:spPr>
+      </p:pic>
+      <p:pic>
+        <p:nvPicPr>
+          <p:cNvPr id="6" name="Image 4" descr="/home/claude/vid/forex_layers/forex_70x70_bar-1__bandeau_blanc.png">    </p:cNvPr>
+          <p:cNvPicPr>
+            <a:picLocks noChangeAspect="1"/>
+          </p:cNvPicPr>
+          <p:nvPr/>
+        </p:nvPicPr>
+        <p:blipFill>
+          <a:blip r:embed="rId5"/>
+          <a:stretch>
+            <a:fillRect/>
+          </a:stretch>
+        </p:blipFill>
+        <p:spPr>
+          <a:xfrm>
+            <a:off x="1260000" y="19958400"/>
+            <a:ext cx="22680000" cy="4572000"/>
+          </a:xfrm>
+          <a:prstGeom prst="rect">
+            <a:avLst/>
+          </a:prstGeom>
+        </p:spPr>
+      </p:pic>
+      <p:pic>
+        <p:nvPicPr>
+          <p:cNvPr id="7" name="Image 5" descr="/home/claude/vid/forex_layers/forex_70x70_bar-1__logo_pegase.png">    </p:cNvPr>
+          <p:cNvPicPr>
+            <a:picLocks noChangeAspect="1"/>
+          </p:cNvPicPr>
+          <p:nvPr/>
+        </p:nvPicPr>
+        <p:blipFill>
+          <a:blip r:embed="rId6"/>
+          <a:stretch>
+            <a:fillRect/>
+          </a:stretch>
+        </p:blipFill>
+        <p:spPr>
+          <a:xfrm>
+            <a:off x="1584000" y="21729600"/>
+            <a:ext cx="2592000" cy="1022400"/>
+          </a:xfrm>
+          <a:prstGeom prst="rect">
+            <a:avLst/>
+          </a:prstGeom>
+        </p:spPr>
+      </p:pic>
+      <p:pic>
+        <p:nvPicPr>
+          <p:cNvPr id="8" name="Image 6" descr="/home/claude/vid/forex_layers/forex_70x70_bar-1__logo_giordano.png">    </p:cNvPr>
+          <p:cNvPicPr>
+            <a:picLocks noChangeAspect="1"/>
+          </p:cNvPicPr>
+          <p:nvPr/>
+        </p:nvPicPr>
+        <p:blipFill>
+          <a:blip r:embed="rId7"/>
+          <a:stretch>
+            <a:fillRect/>
+          </a:stretch>
+        </p:blipFill>
+        <p:spPr>
+          <a:xfrm>
+            <a:off x="4824000" y="21859200"/>
+            <a:ext cx="2592000" cy="763200"/>
+          </a:xfrm>
+          <a:prstGeom prst="rect">
+            <a:avLst/>
+          </a:prstGeom>
+        </p:spPr>
+      </p:pic>
+      <p:pic>
+        <p:nvPicPr>
+          <p:cNvPr id="9" name="Image 7" descr="/home/claude/vid/forex_layers/forex_70x70_bar-1__logo_alafut.png">    </p:cNvPr>
+          <p:cNvPicPr>
+            <a:picLocks noChangeAspect="1"/>
+          </p:cNvPicPr>
+          <p:nvPr/>
+        </p:nvPicPr>
+        <p:blipFill>
+          <a:blip r:embed="rId8"/>
+          <a:stretch>
+            <a:fillRect/>
+          </a:stretch>
+        </p:blipFill>
+        <p:spPr>
+          <a:xfrm>
+            <a:off x="8503200" y="20779200"/>
+            <a:ext cx="1713600" cy="2923200"/>
+          </a:xfrm>
+          <a:prstGeom prst="rect">
+            <a:avLst/>
+          </a:prstGeom>
+        </p:spPr>
+      </p:pic>
+      <p:pic>
+        <p:nvPicPr>
+          <p:cNvPr id="10" name="Image 8" descr="/home/claude/vid/forex_layers/forex_70x70_bar-1__logo_carrosserie-gp.png">    </p:cNvPr>
+          <p:cNvPicPr>
+            <a:picLocks noChangeAspect="1"/>
+          </p:cNvPicPr>
+          <p:nvPr/>
+        </p:nvPicPr>
+        <p:blipFill>
+          <a:blip r:embed="rId9"/>
+          <a:stretch>
+            <a:fillRect/>
+          </a:stretch>
+        </p:blipFill>
+        <p:spPr>
+          <a:xfrm>
+            <a:off x="11304000" y="20944800"/>
+            <a:ext cx="2592000" cy="2592000"/>
+          </a:xfrm>
+          <a:prstGeom prst="rect">
+            <a:avLst/>
+          </a:prstGeom>
+        </p:spPr>
+      </p:pic>
+      <p:pic>
+        <p:nvPicPr>
+          <p:cNvPr id="11" name="Image 9" descr="/home/claude/vid/forex_layers/forex_70x70_bar-1__logo_bergerie.png">    </p:cNvPr>
+          <p:cNvPicPr>
+            <a:picLocks noChangeAspect="1"/>
+          </p:cNvPicPr>
+          <p:nvPr/>
+        </p:nvPicPr>
+        <p:blipFill>
+          <a:blip r:embed="rId10"/>
+          <a:stretch>
+            <a:fillRect/>
+          </a:stretch>
+        </p:blipFill>
+        <p:spPr>
+          <a:xfrm>
+            <a:off x="14544000" y="20988000"/>
+            <a:ext cx="2592000" cy="2512800"/>
+          </a:xfrm>
+          <a:prstGeom prst="rect">
+            <a:avLst/>
+          </a:prstGeom>
+        </p:spPr>
+      </p:pic>
+      <p:pic>
+        <p:nvPicPr>
+          <p:cNvPr id="12" name="Image 10" descr="/home/claude/vid/forex_layers/forex_70x70_bar-1__logo_utile.png">    </p:cNvPr>
+          <p:cNvPicPr>
+            <a:picLocks noChangeAspect="1"/>
+          </p:cNvPicPr>
+          <p:nvPr/>
+        </p:nvPicPr>
+        <p:blipFill>
+          <a:blip r:embed="rId11"/>
+          <a:stretch>
+            <a:fillRect/>
+          </a:stretch>
+        </p:blipFill>
+        <p:spPr>
+          <a:xfrm>
+            <a:off x="17784000" y="21535200"/>
+            <a:ext cx="2592000" cy="1418400"/>
+          </a:xfrm>
+          <a:prstGeom prst="rect">
+            <a:avLst/>
+          </a:prstGeom>
+        </p:spPr>
+      </p:pic>
+      <p:pic>
+        <p:nvPicPr>
+          <p:cNvPr id="13" name="Image 11" descr="/home/claude/vid/forex_layers/forex_70x70_bar-1__logo_charvolin.png">    </p:cNvPr>
+          <p:cNvPicPr>
+            <a:picLocks noChangeAspect="1"/>
+          </p:cNvPicPr>
+          <p:nvPr/>
+        </p:nvPicPr>
+        <p:blipFill>
+          <a:blip r:embed="rId12"/>
+          <a:stretch>
+            <a:fillRect/>
+          </a:stretch>
+        </p:blipFill>
+        <p:spPr>
+          <a:xfrm>
+            <a:off x="21024000" y="21088800"/>
+            <a:ext cx="2592000" cy="2311200"/>
+          </a:xfrm>
+          <a:prstGeom prst="rect">
+            <a:avLst/>
+          </a:prstGeom>
+        </p:spPr>
+      </p:pic>
       <p:sp>
         <p:nvSpPr>
-          <p:cNvPr id="3" name="Text 0"/>
+          <p:cNvPr id="14" name="Text 0"/>
           <p:cNvSpPr/>
           <p:nvPr/>
         </p:nvSpPr>
@@ -935,7 +1199,7 @@
       </p:sp>
       <p:sp>
         <p:nvSpPr>
-          <p:cNvPr id="4" name="Text 1"/>
+          <p:cNvPr id="15" name="Text 1"/>
           <p:cNvSpPr/>
           <p:nvPr/>
         </p:nvSpPr>
@@ -976,7 +1240,7 @@
       </p:sp>
       <p:sp>
         <p:nvSpPr>
-          <p:cNvPr id="5" name="Text 2"/>
+          <p:cNvPr id="16" name="Text 2"/>
           <p:cNvSpPr/>
           <p:nvPr/>
         </p:nvSpPr>
@@ -1017,7 +1281,7 @@
       </p:sp>
       <p:sp>
         <p:nvSpPr>
-          <p:cNvPr id="6" name="Text 3"/>
+          <p:cNvPr id="17" name="Text 3"/>
           <p:cNvSpPr/>
           <p:nvPr/>
         </p:nvSpPr>

</xml_diff>

<commit_message>
feat(DEKRA): forex PPTX editables regeneres a 8 logos (caisses+bars+festival)
</commit_message>
<xml_diff>
--- a/admin/public/nds/kit-digital/svg/forex_70x70_bar-1-editable.pptx
+++ b/admin/public/nds/kit-digital/svg/forex_70x70_bar-1-editable.pptx
@@ -870,7 +870,7 @@
       </p:grpSpPr>
       <p:pic>
         <p:nvPicPr>
-          <p:cNvPr id="2" name="Image 0" descr="/home/claude/vid/forex_layers/forex_70x70_bar-1__bg.png">    </p:cNvPr>
+          <p:cNvPr id="2" name="Image 0" descr="/home/claude/vid/forex_plates/plate_forex_70x70_bar-1.png">    </p:cNvPr>
           <p:cNvPicPr>
             <a:picLocks noChangeAspect="1"/>
           </p:cNvPicPr>
@@ -892,273 +892,9 @@
           </a:prstGeom>
         </p:spPr>
       </p:pic>
-      <p:pic>
-        <p:nvPicPr>
-          <p:cNvPr id="3" name="Image 1" descr="/home/claude/vid/forex_layers/forex_70x70_bar-1__logo_nds.png">    </p:cNvPr>
-          <p:cNvPicPr>
-            <a:picLocks noChangeAspect="1"/>
-          </p:cNvPicPr>
-          <p:nvPr/>
-        </p:nvPicPr>
-        <p:blipFill>
-          <a:blip r:embed="rId2"/>
-          <a:stretch>
-            <a:fillRect/>
-          </a:stretch>
-        </p:blipFill>
-        <p:spPr>
-          <a:xfrm>
-            <a:off x="9028800" y="1022400"/>
-            <a:ext cx="7178400" cy="2311200"/>
-          </a:xfrm>
-          <a:prstGeom prst="rect">
-            <a:avLst/>
-          </a:prstGeom>
-        </p:spPr>
-      </p:pic>
-      <p:pic>
-        <p:nvPicPr>
-          <p:cNvPr id="4" name="Image 2" descr="/home/claude/vid/forex_layers/forex_70x70_bar-1__chip_station.png">    </p:cNvPr>
-          <p:cNvPicPr>
-            <a:picLocks noChangeAspect="1"/>
-          </p:cNvPicPr>
-          <p:nvPr/>
-        </p:nvPicPr>
-        <p:blipFill>
-          <a:blip r:embed="rId3"/>
-          <a:stretch>
-            <a:fillRect/>
-          </a:stretch>
-        </p:blipFill>
-        <p:spPr>
-          <a:xfrm>
-            <a:off x="20124000" y="1173600"/>
-            <a:ext cx="3679200" cy="1310400"/>
-          </a:xfrm>
-          <a:prstGeom prst="rect">
-            <a:avLst/>
-          </a:prstGeom>
-        </p:spPr>
-      </p:pic>
-      <p:pic>
-        <p:nvPicPr>
-          <p:cNvPr id="5" name="Image 3" descr="/home/claude/vid/forex_layers/forex_70x70_bar-1__qr.png">    </p:cNvPr>
-          <p:cNvPicPr>
-            <a:picLocks noChangeAspect="1"/>
-          </p:cNvPicPr>
-          <p:nvPr/>
-        </p:nvPicPr>
-        <p:blipFill>
-          <a:blip r:embed="rId4"/>
-          <a:stretch>
-            <a:fillRect/>
-          </a:stretch>
-        </p:blipFill>
-        <p:spPr>
-          <a:xfrm>
-            <a:off x="7387200" y="7790400"/>
-            <a:ext cx="10418400" cy="10418400"/>
-          </a:xfrm>
-          <a:prstGeom prst="rect">
-            <a:avLst/>
-          </a:prstGeom>
-        </p:spPr>
-      </p:pic>
-      <p:pic>
-        <p:nvPicPr>
-          <p:cNvPr id="6" name="Image 4" descr="/home/claude/vid/forex_layers/forex_70x70_bar-1__bandeau_blanc.png">    </p:cNvPr>
-          <p:cNvPicPr>
-            <a:picLocks noChangeAspect="1"/>
-          </p:cNvPicPr>
-          <p:nvPr/>
-        </p:nvPicPr>
-        <p:blipFill>
-          <a:blip r:embed="rId5"/>
-          <a:stretch>
-            <a:fillRect/>
-          </a:stretch>
-        </p:blipFill>
-        <p:spPr>
-          <a:xfrm>
-            <a:off x="1260000" y="19958400"/>
-            <a:ext cx="22680000" cy="4572000"/>
-          </a:xfrm>
-          <a:prstGeom prst="rect">
-            <a:avLst/>
-          </a:prstGeom>
-        </p:spPr>
-      </p:pic>
-      <p:pic>
-        <p:nvPicPr>
-          <p:cNvPr id="7" name="Image 5" descr="/home/claude/vid/forex_layers/forex_70x70_bar-1__logo_pegase.png">    </p:cNvPr>
-          <p:cNvPicPr>
-            <a:picLocks noChangeAspect="1"/>
-          </p:cNvPicPr>
-          <p:nvPr/>
-        </p:nvPicPr>
-        <p:blipFill>
-          <a:blip r:embed="rId6"/>
-          <a:stretch>
-            <a:fillRect/>
-          </a:stretch>
-        </p:blipFill>
-        <p:spPr>
-          <a:xfrm>
-            <a:off x="1584000" y="21729600"/>
-            <a:ext cx="2592000" cy="1022400"/>
-          </a:xfrm>
-          <a:prstGeom prst="rect">
-            <a:avLst/>
-          </a:prstGeom>
-        </p:spPr>
-      </p:pic>
-      <p:pic>
-        <p:nvPicPr>
-          <p:cNvPr id="8" name="Image 6" descr="/home/claude/vid/forex_layers/forex_70x70_bar-1__logo_giordano.png">    </p:cNvPr>
-          <p:cNvPicPr>
-            <a:picLocks noChangeAspect="1"/>
-          </p:cNvPicPr>
-          <p:nvPr/>
-        </p:nvPicPr>
-        <p:blipFill>
-          <a:blip r:embed="rId7"/>
-          <a:stretch>
-            <a:fillRect/>
-          </a:stretch>
-        </p:blipFill>
-        <p:spPr>
-          <a:xfrm>
-            <a:off x="4824000" y="21859200"/>
-            <a:ext cx="2592000" cy="763200"/>
-          </a:xfrm>
-          <a:prstGeom prst="rect">
-            <a:avLst/>
-          </a:prstGeom>
-        </p:spPr>
-      </p:pic>
-      <p:pic>
-        <p:nvPicPr>
-          <p:cNvPr id="9" name="Image 7" descr="/home/claude/vid/forex_layers/forex_70x70_bar-1__logo_alafut.png">    </p:cNvPr>
-          <p:cNvPicPr>
-            <a:picLocks noChangeAspect="1"/>
-          </p:cNvPicPr>
-          <p:nvPr/>
-        </p:nvPicPr>
-        <p:blipFill>
-          <a:blip r:embed="rId8"/>
-          <a:stretch>
-            <a:fillRect/>
-          </a:stretch>
-        </p:blipFill>
-        <p:spPr>
-          <a:xfrm>
-            <a:off x="8503200" y="20779200"/>
-            <a:ext cx="1713600" cy="2923200"/>
-          </a:xfrm>
-          <a:prstGeom prst="rect">
-            <a:avLst/>
-          </a:prstGeom>
-        </p:spPr>
-      </p:pic>
-      <p:pic>
-        <p:nvPicPr>
-          <p:cNvPr id="10" name="Image 8" descr="/home/claude/vid/forex_layers/forex_70x70_bar-1__logo_carrosserie-gp.png">    </p:cNvPr>
-          <p:cNvPicPr>
-            <a:picLocks noChangeAspect="1"/>
-          </p:cNvPicPr>
-          <p:nvPr/>
-        </p:nvPicPr>
-        <p:blipFill>
-          <a:blip r:embed="rId9"/>
-          <a:stretch>
-            <a:fillRect/>
-          </a:stretch>
-        </p:blipFill>
-        <p:spPr>
-          <a:xfrm>
-            <a:off x="11304000" y="20944800"/>
-            <a:ext cx="2592000" cy="2592000"/>
-          </a:xfrm>
-          <a:prstGeom prst="rect">
-            <a:avLst/>
-          </a:prstGeom>
-        </p:spPr>
-      </p:pic>
-      <p:pic>
-        <p:nvPicPr>
-          <p:cNvPr id="11" name="Image 9" descr="/home/claude/vid/forex_layers/forex_70x70_bar-1__logo_bergerie.png">    </p:cNvPr>
-          <p:cNvPicPr>
-            <a:picLocks noChangeAspect="1"/>
-          </p:cNvPicPr>
-          <p:nvPr/>
-        </p:nvPicPr>
-        <p:blipFill>
-          <a:blip r:embed="rId10"/>
-          <a:stretch>
-            <a:fillRect/>
-          </a:stretch>
-        </p:blipFill>
-        <p:spPr>
-          <a:xfrm>
-            <a:off x="14544000" y="20988000"/>
-            <a:ext cx="2592000" cy="2512800"/>
-          </a:xfrm>
-          <a:prstGeom prst="rect">
-            <a:avLst/>
-          </a:prstGeom>
-        </p:spPr>
-      </p:pic>
-      <p:pic>
-        <p:nvPicPr>
-          <p:cNvPr id="12" name="Image 10" descr="/home/claude/vid/forex_layers/forex_70x70_bar-1__logo_utile.png">    </p:cNvPr>
-          <p:cNvPicPr>
-            <a:picLocks noChangeAspect="1"/>
-          </p:cNvPicPr>
-          <p:nvPr/>
-        </p:nvPicPr>
-        <p:blipFill>
-          <a:blip r:embed="rId11"/>
-          <a:stretch>
-            <a:fillRect/>
-          </a:stretch>
-        </p:blipFill>
-        <p:spPr>
-          <a:xfrm>
-            <a:off x="17784000" y="21535200"/>
-            <a:ext cx="2592000" cy="1418400"/>
-          </a:xfrm>
-          <a:prstGeom prst="rect">
-            <a:avLst/>
-          </a:prstGeom>
-        </p:spPr>
-      </p:pic>
-      <p:pic>
-        <p:nvPicPr>
-          <p:cNvPr id="13" name="Image 11" descr="/home/claude/vid/forex_layers/forex_70x70_bar-1__logo_charvolin.png">    </p:cNvPr>
-          <p:cNvPicPr>
-            <a:picLocks noChangeAspect="1"/>
-          </p:cNvPicPr>
-          <p:nvPr/>
-        </p:nvPicPr>
-        <p:blipFill>
-          <a:blip r:embed="rId12"/>
-          <a:stretch>
-            <a:fillRect/>
-          </a:stretch>
-        </p:blipFill>
-        <p:spPr>
-          <a:xfrm>
-            <a:off x="21024000" y="21088800"/>
-            <a:ext cx="2592000" cy="2311200"/>
-          </a:xfrm>
-          <a:prstGeom prst="rect">
-            <a:avLst/>
-          </a:prstGeom>
-        </p:spPr>
-      </p:pic>
       <p:sp>
         <p:nvSpPr>
-          <p:cNvPr id="14" name="Text 0"/>
+          <p:cNvPr id="3" name="Text 0"/>
           <p:cNvSpPr/>
           <p:nvPr/>
         </p:nvSpPr>
@@ -1199,7 +935,7 @@
       </p:sp>
       <p:sp>
         <p:nvSpPr>
-          <p:cNvPr id="15" name="Text 1"/>
+          <p:cNvPr id="4" name="Text 1"/>
           <p:cNvSpPr/>
           <p:nvPr/>
         </p:nvSpPr>
@@ -1240,7 +976,7 @@
       </p:sp>
       <p:sp>
         <p:nvSpPr>
-          <p:cNvPr id="16" name="Text 2"/>
+          <p:cNvPr id="5" name="Text 2"/>
           <p:cNvSpPr/>
           <p:nvPr/>
         </p:nvSpPr>
@@ -1281,7 +1017,7 @@
       </p:sp>
       <p:sp>
         <p:nvSpPr>
-          <p:cNvPr id="17" name="Text 3"/>
+          <p:cNvPr id="6" name="Text 3"/>
           <p:cNvSpPr/>
           <p:nvPr/>
         </p:nvSpPr>

</xml_diff>